<commit_message>
Final commit with presentation and 'run_pipeline.r' script for smoother run.
</commit_message>
<xml_diff>
--- a/SHEIN_Data_Cleaning_Presentation.pptx
+++ b/SHEIN_Data_Cleaning_Presentation.pptx
@@ -448,7 +448,14 @@
   <c:date1904 val="0"/>
   <c:lang val="en-US"/>
   <c:roundedCorners val="1"/>
-  <c:style val="2"/>
+  <mc:AlternateContent xmlns:mc="http://schemas.openxmlformats.org/markup-compatibility/2006">
+    <mc:Choice xmlns:c14="http://schemas.microsoft.com/office/drawing/2007/8/2/chart" Requires="c14">
+      <c14:style val="102"/>
+    </mc:Choice>
+    <mc:Fallback>
+      <c:style val="2"/>
+    </mc:Fallback>
+  </mc:AlternateContent>
   <c:chart>
     <c:autoTitleDeleted val="1"/>
     <c:plotArea>
@@ -499,7 +506,7 @@
                     <a:latin typeface="Arial"/>
                   </a:defRPr>
                 </a:pPr>
-                <a:endParaRPr lang="en-US"/>
+                <a:endParaRPr lang="en-GY"/>
               </a:p>
             </c:txPr>
             <c:showLegendKey val="0"/>
@@ -517,9 +524,9 @@
           </c:dLbls>
           <c:cat>
             <c:strRef>
-              <c:f>Sheet1!$A$2:$A$7</c:f>
+              <c:f>Sheet1!$A$2:$A$9</c:f>
               <c:strCache>
-                <c:ptCount val="6"/>
+                <c:ptCount val="8"/>
                 <c:pt idx="0">
                   <c:v>Repo setup &amp; LFS</c:v>
                 </c:pt>
@@ -536,41 +543,53 @@
                   <c:v>Size system classification</c:v>
                 </c:pt>
                 <c:pt idx="5">
+                  <c:v>Imputation</c:v>
+                </c:pt>
+                <c:pt idx="6">
                   <c:v>Report &amp; presentation</c:v>
+                </c:pt>
+                <c:pt idx="7">
+                  <c:v>Finalizing details</c:v>
                 </c:pt>
               </c:strCache>
             </c:strRef>
           </c:cat>
           <c:val>
             <c:numRef>
-              <c:f>Sheet1!$B$2:$B$7</c:f>
+              <c:f>Sheet1!$B$2:$B$9</c:f>
               <c:numCache>
                 <c:formatCode>General</c:formatCode>
-                <c:ptCount val="6"/>
+                <c:ptCount val="8"/>
                 <c:pt idx="0">
-                  <c:v>2</c:v>
+                  <c:v>6</c:v>
                 </c:pt>
                 <c:pt idx="1">
-                  <c:v>1.5</c:v>
+                  <c:v>4</c:v>
                 </c:pt>
                 <c:pt idx="2">
+                  <c:v>5</c:v>
+                </c:pt>
+                <c:pt idx="3">
+                  <c:v>6</c:v>
+                </c:pt>
+                <c:pt idx="4">
+                  <c:v>7</c:v>
+                </c:pt>
+                <c:pt idx="5">
                   <c:v>4</c:v>
                 </c:pt>
-                <c:pt idx="3">
-                  <c:v>3</c:v>
+                <c:pt idx="6">
+                  <c:v>8</c:v>
                 </c:pt>
-                <c:pt idx="4">
-                  <c:v>3</c:v>
-                </c:pt>
-                <c:pt idx="5">
-                  <c:v>1.5</c:v>
+                <c:pt idx="7">
+                  <c:v>6</c:v>
                 </c:pt>
               </c:numCache>
             </c:numRef>
           </c:val>
           <c:extLst>
             <c:ext xmlns:c16="http://schemas.microsoft.com/office/drawing/2014/chart" uri="{C3380CC4-5D6E-409C-BE32-E72D297353CC}">
-              <c16:uniqueId val="{00000000-1F3C-41B5-AD21-FE22E068BAB7}"/>
+              <c16:uniqueId val="{00000000-AD14-4597-9F49-ED46208A56EC}"/>
             </c:ext>
           </c:extLst>
         </c:ser>
@@ -5068,36 +5087,15 @@
           <a:chExt cx="0" cy="0"/>
         </a:xfrm>
       </p:grpSpPr>
-      <p:sp>
-        <p:nvSpPr>
-          <p:cNvPr id="2" name="Shape 0"/>
-          <p:cNvSpPr/>
-          <p:nvPr/>
-        </p:nvSpPr>
-        <p:spPr>
-          <a:xfrm>
-            <a:off x="457200" y="320040"/>
-            <a:ext cx="457200" cy="457200"/>
-          </a:xfrm>
-          <a:prstGeom prst="ellipse">
-            <a:avLst/>
-          </a:prstGeom>
-          <a:solidFill>
-            <a:srgbClr val="065A82"/>
-          </a:solidFill>
-          <a:ln/>
-        </p:spPr>
-        <p:txBody>
-          <a:bodyPr/>
-          <a:lstStyle/>
-          <a:p>
-            <a:endParaRPr lang="en-US"/>
-          </a:p>
-        </p:txBody>
-      </p:sp>
       <p:pic>
         <p:nvPicPr>
-          <p:cNvPr id="3" name="Image 0" descr="preencoded.png"/>
+          <p:cNvPr id="8" name="Image 0" descr="preencoded.png">
+            <a:extLst>
+              <a:ext uri="{FF2B5EF4-FFF2-40B4-BE49-F238E27FC236}">
+                <a16:creationId xmlns:a16="http://schemas.microsoft.com/office/drawing/2014/main" id="{8422DD41-034F-7CE3-9BFD-CFAE14E7EF45}"/>
+              </a:ext>
+            </a:extLst>
+          </p:cNvPr>
           <p:cNvPicPr>
             <a:picLocks noChangeAspect="1"/>
           </p:cNvPicPr>
@@ -5111,17 +5109,130 @@
         </p:blipFill>
         <p:spPr>
           <a:xfrm>
-            <a:off x="557784" y="420624"/>
-            <a:ext cx="256032" cy="256032"/>
+            <a:off x="457200" y="320040"/>
+            <a:ext cx="457200" cy="457200"/>
           </a:xfrm>
           <a:prstGeom prst="rect">
             <a:avLst/>
           </a:prstGeom>
         </p:spPr>
       </p:pic>
-      <p:sp>
-        <p:nvSpPr>
-          <p:cNvPr id="4" name="Text 1"/>
+      <p:graphicFrame>
+        <p:nvGraphicFramePr>
+          <p:cNvPr id="9" name="Chart 0">
+            <a:extLst>
+              <a:ext uri="{FF2B5EF4-FFF2-40B4-BE49-F238E27FC236}">
+                <a16:creationId xmlns:a16="http://schemas.microsoft.com/office/drawing/2014/main" id="{CE0E4BF9-A4E5-47A8-1A86-8309BE210A0E}"/>
+              </a:ext>
+            </a:extLst>
+          </p:cNvPr>
+          <p:cNvGraphicFramePr/>
+          <p:nvPr/>
+        </p:nvGraphicFramePr>
+        <p:xfrm>
+          <a:off x="457200" y="1005840"/>
+          <a:ext cx="8229600" cy="3200400"/>
+        </p:xfrm>
+        <a:graphic>
+          <a:graphicData uri="http://schemas.openxmlformats.org/drawingml/2006/chart">
+            <c:chart xmlns:c="http://schemas.openxmlformats.org/drawingml/2006/chart" xmlns:r="http://schemas.openxmlformats.org/officeDocument/2006/relationships" r:id="rId4"/>
+          </a:graphicData>
+        </a:graphic>
+      </p:graphicFrame>
+      <p:sp>
+        <p:nvSpPr>
+          <p:cNvPr id="10" name="Shape 2">
+            <a:extLst>
+              <a:ext uri="{FF2B5EF4-FFF2-40B4-BE49-F238E27FC236}">
+                <a16:creationId xmlns:a16="http://schemas.microsoft.com/office/drawing/2014/main" id="{20DF1412-E17B-C483-432C-CA9F425822C5}"/>
+              </a:ext>
+            </a:extLst>
+          </p:cNvPr>
+          <p:cNvSpPr/>
+          <p:nvPr/>
+        </p:nvSpPr>
+        <p:spPr>
+          <a:xfrm>
+            <a:off x="3200400" y="4389120"/>
+            <a:ext cx="2743200" cy="502920"/>
+          </a:xfrm>
+          <a:prstGeom prst="rect">
+            <a:avLst/>
+          </a:prstGeom>
+          <a:solidFill>
+            <a:srgbClr val="21295C"/>
+          </a:solidFill>
+          <a:ln/>
+          <a:effectLst>
+            <a:outerShdw blurRad="76200" dist="25400" dir="8100000" algn="bl" rotWithShape="0">
+              <a:srgbClr val="000000">
+                <a:alpha val="12000"/>
+              </a:srgbClr>
+            </a:outerShdw>
+          </a:effectLst>
+        </p:spPr>
+        <p:txBody>
+          <a:bodyPr/>
+          <a:lstStyle/>
+          <a:p>
+            <a:endParaRPr lang="en-GY"/>
+          </a:p>
+        </p:txBody>
+      </p:sp>
+      <p:sp>
+        <p:nvSpPr>
+          <p:cNvPr id="11" name="Text 3">
+            <a:extLst>
+              <a:ext uri="{FF2B5EF4-FFF2-40B4-BE49-F238E27FC236}">
+                <a16:creationId xmlns:a16="http://schemas.microsoft.com/office/drawing/2014/main" id="{741525D9-8ABF-DEDE-1081-0A2C96A2C6D8}"/>
+              </a:ext>
+            </a:extLst>
+          </p:cNvPr>
+          <p:cNvSpPr/>
+          <p:nvPr/>
+        </p:nvSpPr>
+        <p:spPr>
+          <a:xfrm>
+            <a:off x="3200400" y="4389120"/>
+            <a:ext cx="2743200" cy="502920"/>
+          </a:xfrm>
+          <a:prstGeom prst="rect">
+            <a:avLst/>
+          </a:prstGeom>
+          <a:noFill/>
+          <a:ln/>
+        </p:spPr>
+        <p:txBody>
+          <a:bodyPr wrap="square" lIns="0" tIns="0" rIns="0" bIns="0" rtlCol="0" anchor="ctr"/>
+          <a:lstStyle/>
+          <a:p>
+            <a:pPr marL="0" indent="0" algn="ctr">
+              <a:buNone/>
+            </a:pPr>
+            <a:r>
+              <a:rPr lang="en-US" sz="1800" b="1" dirty="0">
+                <a:solidFill>
+                  <a:srgbClr val="FFFFFF"/>
+                </a:solidFill>
+                <a:latin typeface="Georgia" pitchFamily="34" charset="0"/>
+                <a:ea typeface="Georgia" pitchFamily="34" charset="-122"/>
+                <a:cs typeface="Georgia" pitchFamily="34" charset="-120"/>
+              </a:rPr>
+              <a:t>Total: ~46 hours</a:t>
+            </a:r>
+            <a:endParaRPr lang="en-US" sz="1800" dirty="0"/>
+          </a:p>
+        </p:txBody>
+      </p:sp>
+      <p:sp>
+        <p:nvSpPr>
+          <p:cNvPr id="12" name="Text 1">
+            <a:extLst>
+              <a:ext uri="{FF2B5EF4-FFF2-40B4-BE49-F238E27FC236}">
+                <a16:creationId xmlns:a16="http://schemas.microsoft.com/office/drawing/2014/main" id="{322B1E12-4908-F3D3-0796-CD6AFB4462F2}"/>
+              </a:ext>
+            </a:extLst>
+          </p:cNvPr>
           <p:cNvSpPr/>
           <p:nvPr/>
         </p:nvSpPr>
@@ -5155,101 +5266,6 @@
               <a:t>Time Breakdown</a:t>
             </a:r>
             <a:endParaRPr lang="en-US" sz="3200" dirty="0"/>
-          </a:p>
-        </p:txBody>
-      </p:sp>
-      <p:graphicFrame>
-        <p:nvGraphicFramePr>
-          <p:cNvPr id="5" name="Chart 0"/>
-          <p:cNvGraphicFramePr/>
-          <p:nvPr>
-            <p:extLst>
-              <p:ext uri="{D42A27DB-BD31-4B8C-83A1-F6EECF244321}">
-                <p14:modId xmlns:p14="http://schemas.microsoft.com/office/powerpoint/2010/main" val="816260906"/>
-              </p:ext>
-            </p:extLst>
-          </p:nvPr>
-        </p:nvGraphicFramePr>
-        <p:xfrm>
-          <a:off x="457200" y="1005840"/>
-          <a:ext cx="8229600" cy="3200400"/>
-        </p:xfrm>
-        <a:graphic>
-          <a:graphicData uri="http://schemas.openxmlformats.org/drawingml/2006/chart">
-            <c:chart xmlns:c="http://schemas.openxmlformats.org/drawingml/2006/chart" xmlns:r="http://schemas.openxmlformats.org/officeDocument/2006/relationships" r:id="rId4"/>
-          </a:graphicData>
-        </a:graphic>
-      </p:graphicFrame>
-      <p:sp>
-        <p:nvSpPr>
-          <p:cNvPr id="6" name="Shape 2"/>
-          <p:cNvSpPr/>
-          <p:nvPr/>
-        </p:nvSpPr>
-        <p:spPr>
-          <a:xfrm>
-            <a:off x="3200400" y="4389120"/>
-            <a:ext cx="2743200" cy="502920"/>
-          </a:xfrm>
-          <a:prstGeom prst="rect">
-            <a:avLst/>
-          </a:prstGeom>
-          <a:solidFill>
-            <a:srgbClr val="21295C"/>
-          </a:solidFill>
-          <a:ln/>
-          <a:effectLst>
-            <a:outerShdw blurRad="76200" dist="25400" dir="8100000" algn="bl" rotWithShape="0">
-              <a:srgbClr val="000000">
-                <a:alpha val="12000"/>
-              </a:srgbClr>
-            </a:outerShdw>
-          </a:effectLst>
-        </p:spPr>
-        <p:txBody>
-          <a:bodyPr/>
-          <a:lstStyle/>
-          <a:p>
-            <a:endParaRPr lang="en-US"/>
-          </a:p>
-        </p:txBody>
-      </p:sp>
-      <p:sp>
-        <p:nvSpPr>
-          <p:cNvPr id="7" name="Text 3"/>
-          <p:cNvSpPr/>
-          <p:nvPr/>
-        </p:nvSpPr>
-        <p:spPr>
-          <a:xfrm>
-            <a:off x="3200400" y="4389120"/>
-            <a:ext cx="2743200" cy="502920"/>
-          </a:xfrm>
-          <a:prstGeom prst="rect">
-            <a:avLst/>
-          </a:prstGeom>
-          <a:noFill/>
-          <a:ln/>
-        </p:spPr>
-        <p:txBody>
-          <a:bodyPr wrap="square" lIns="0" tIns="0" rIns="0" bIns="0" rtlCol="0" anchor="ctr"/>
-          <a:lstStyle/>
-          <a:p>
-            <a:pPr marL="0" indent="0" algn="ctr">
-              <a:buNone/>
-            </a:pPr>
-            <a:r>
-              <a:rPr lang="en-US" sz="1800" b="1" dirty="0">
-                <a:solidFill>
-                  <a:srgbClr val="FFFFFF"/>
-                </a:solidFill>
-                <a:latin typeface="Georgia" pitchFamily="34" charset="0"/>
-                <a:ea typeface="Georgia" pitchFamily="34" charset="-122"/>
-                <a:cs typeface="Georgia" pitchFamily="34" charset="-120"/>
-              </a:rPr>
-              <a:t>Total: ~15 hours</a:t>
-            </a:r>
-            <a:endParaRPr lang="en-US" sz="1800" dirty="0"/>
           </a:p>
         </p:txBody>
       </p:sp>
@@ -5795,13 +5811,13 @@
       </p:sp>
       <p:sp>
         <p:nvSpPr>
-          <p:cNvPr id="17" name="Shape 14"/>
-          <p:cNvSpPr/>
-          <p:nvPr/>
-        </p:nvSpPr>
-        <p:spPr>
-          <a:xfrm>
-            <a:off x="457200" y="3337560"/>
+          <p:cNvPr id="21" name="Shape 18"/>
+          <p:cNvSpPr/>
+          <p:nvPr/>
+        </p:nvSpPr>
+        <p:spPr>
+          <a:xfrm>
+            <a:off x="457200" y="3474720"/>
             <a:ext cx="8229600" cy="685800"/>
           </a:xfrm>
           <a:prstGeom prst="rect">
@@ -5829,13 +5845,13 @@
       </p:sp>
       <p:sp>
         <p:nvSpPr>
-          <p:cNvPr id="18" name="Shape 15"/>
-          <p:cNvSpPr/>
-          <p:nvPr/>
-        </p:nvSpPr>
-        <p:spPr>
-          <a:xfrm>
-            <a:off x="457200" y="3337560"/>
+          <p:cNvPr id="22" name="Shape 19"/>
+          <p:cNvSpPr/>
+          <p:nvPr/>
+        </p:nvSpPr>
+        <p:spPr>
+          <a:xfrm>
+            <a:off x="457200" y="3474720"/>
             <a:ext cx="54864" cy="685800"/>
           </a:xfrm>
           <a:prstGeom prst="rect">
@@ -5856,152 +5872,13 @@
       </p:sp>
       <p:sp>
         <p:nvSpPr>
-          <p:cNvPr id="19" name="Text 16"/>
-          <p:cNvSpPr/>
-          <p:nvPr/>
-        </p:nvSpPr>
-        <p:spPr>
-          <a:xfrm>
-            <a:off x="685800" y="3383280"/>
-            <a:ext cx="7772400" cy="274320"/>
-          </a:xfrm>
-          <a:prstGeom prst="rect">
-            <a:avLst/>
-          </a:prstGeom>
-          <a:noFill/>
-          <a:ln/>
-        </p:spPr>
-        <p:txBody>
-          <a:bodyPr wrap="square" lIns="0" tIns="0" rIns="0" bIns="0" rtlCol="0" anchor="ctr"/>
-          <a:lstStyle/>
-          <a:p>
-            <a:pPr marL="0" indent="0">
-              <a:buNone/>
-            </a:pPr>
-            <a:r>
-              <a:rPr lang="en-US" sz="1400" b="1" dirty="0">
-                <a:solidFill>
-                  <a:srgbClr val="21295C"/>
-                </a:solidFill>
-                <a:latin typeface="Calibri" pitchFamily="34" charset="0"/>
-                <a:ea typeface="Calibri" pitchFamily="34" charset="-122"/>
-                <a:cs typeface="Calibri" pitchFamily="34" charset="-120"/>
-              </a:rPr>
-              <a:t>Reproducible master script</a:t>
-            </a:r>
-            <a:endParaRPr lang="en-US" sz="1400" dirty="0"/>
-          </a:p>
-        </p:txBody>
-      </p:sp>
-      <p:sp>
-        <p:nvSpPr>
-          <p:cNvPr id="20" name="Text 17"/>
-          <p:cNvSpPr/>
-          <p:nvPr/>
-        </p:nvSpPr>
-        <p:spPr>
-          <a:xfrm>
-            <a:off x="685800" y="3685032"/>
-            <a:ext cx="7772400" cy="274320"/>
-          </a:xfrm>
-          <a:prstGeom prst="rect">
-            <a:avLst/>
-          </a:prstGeom>
-          <a:noFill/>
-          <a:ln/>
-        </p:spPr>
-        <p:txBody>
-          <a:bodyPr wrap="square" lIns="0" tIns="0" rIns="0" bIns="0" rtlCol="0" anchor="ctr"/>
-          <a:lstStyle/>
-          <a:p>
-            <a:pPr marL="0" indent="0">
-              <a:buNone/>
-            </a:pPr>
-            <a:r>
-              <a:rPr lang="en-US" sz="1200" dirty="0">
-                <a:solidFill>
-                  <a:srgbClr val="64748B"/>
-                </a:solidFill>
-                <a:latin typeface="Calibri" pitchFamily="34" charset="0"/>
-                <a:ea typeface="Calibri" pitchFamily="34" charset="-122"/>
-                <a:cs typeface="Calibri" pitchFamily="34" charset="-120"/>
-              </a:rPr>
-              <a:t>Single run_pipeline.R that sources all scripts in order with error handling and timing.</a:t>
-            </a:r>
-            <a:endParaRPr lang="en-US" sz="1200" dirty="0"/>
-          </a:p>
-        </p:txBody>
-      </p:sp>
-      <p:sp>
-        <p:nvSpPr>
-          <p:cNvPr id="21" name="Shape 18"/>
-          <p:cNvSpPr/>
-          <p:nvPr/>
-        </p:nvSpPr>
-        <p:spPr>
-          <a:xfrm>
-            <a:off x="457200" y="4114800"/>
-            <a:ext cx="8229600" cy="685800"/>
-          </a:xfrm>
-          <a:prstGeom prst="rect">
-            <a:avLst/>
-          </a:prstGeom>
-          <a:solidFill>
-            <a:srgbClr val="FFFFFF"/>
-          </a:solidFill>
-          <a:ln/>
-          <a:effectLst>
-            <a:outerShdw blurRad="76200" dist="25400" dir="8100000" algn="bl" rotWithShape="0">
-              <a:srgbClr val="000000">
-                <a:alpha val="12000"/>
-              </a:srgbClr>
-            </a:outerShdw>
-          </a:effectLst>
-        </p:spPr>
-        <p:txBody>
-          <a:bodyPr/>
-          <a:lstStyle/>
-          <a:p>
-            <a:endParaRPr lang="en-US"/>
-          </a:p>
-        </p:txBody>
-      </p:sp>
-      <p:sp>
-        <p:nvSpPr>
-          <p:cNvPr id="22" name="Shape 19"/>
-          <p:cNvSpPr/>
-          <p:nvPr/>
-        </p:nvSpPr>
-        <p:spPr>
-          <a:xfrm>
-            <a:off x="457200" y="4114800"/>
-            <a:ext cx="54864" cy="685800"/>
-          </a:xfrm>
-          <a:prstGeom prst="rect">
-            <a:avLst/>
-          </a:prstGeom>
-          <a:solidFill>
-            <a:srgbClr val="0EA5E9"/>
-          </a:solidFill>
-          <a:ln/>
-        </p:spPr>
-        <p:txBody>
-          <a:bodyPr/>
-          <a:lstStyle/>
-          <a:p>
-            <a:endParaRPr lang="en-US"/>
-          </a:p>
-        </p:txBody>
-      </p:sp>
-      <p:sp>
-        <p:nvSpPr>
           <p:cNvPr id="23" name="Text 20"/>
           <p:cNvSpPr/>
           <p:nvPr/>
         </p:nvSpPr>
         <p:spPr>
           <a:xfrm>
-            <a:off x="685800" y="4160520"/>
+            <a:off x="685800" y="3520440"/>
             <a:ext cx="7772400" cy="274320"/>
           </a:xfrm>
           <a:prstGeom prst="rect">
@@ -6040,7 +5917,7 @@
         </p:nvSpPr>
         <p:spPr>
           <a:xfrm>
-            <a:off x="685800" y="4462272"/>
+            <a:off x="685800" y="3822192"/>
             <a:ext cx="7772400" cy="274320"/>
           </a:xfrm>
           <a:prstGeom prst="rect">
@@ -7686,7 +7563,7 @@
                 <a:ea typeface="Calibri" pitchFamily="34" charset="-122"/>
                 <a:cs typeface="Calibri" pitchFamily="34" charset="-120"/>
               </a:rPr>
-              <a:t>Left as is </a:t>
+              <a:t>Left as is, image URLs counted </a:t>
             </a:r>
           </a:p>
         </p:txBody>
@@ -9686,7 +9563,7 @@
           <p:nvPr>
             <p:extLst>
               <p:ext uri="{D42A27DB-BD31-4B8C-83A1-F6EECF244321}">
-                <p14:modId xmlns:p14="http://schemas.microsoft.com/office/powerpoint/2010/main" val="1892655814"/>
+                <p14:modId xmlns:p14="http://schemas.microsoft.com/office/powerpoint/2010/main" val="1331011422"/>
               </p:ext>
             </p:extLst>
           </p:nvPr>
@@ -10081,7 +9958,7 @@
                           <a:ea typeface="Calibri" pitchFamily="34" charset="-122"/>
                           <a:cs typeface="Calibri" pitchFamily="34" charset="-120"/>
                         </a:rPr>
-                        <a:t>Primary key; ~50% rows removed</a:t>
+                        <a:t>Primary key; 7.18% rows removed</a:t>
                       </a:r>
                       <a:endParaRPr lang="en-US" sz="1200" dirty="0">
                         <a:latin typeface="Calibri" charset="0"/>

</xml_diff>